<commit_message>
Procesevaluatie tweede controle: taal en consistentie in eCRF 40-44, deck rechtgezet
Opnieuw opgebouwd vanaf de originelen, alles als bijgehouden wijzigingen: gidsen 41-43 overal in u,
inleiding en openingsvragen van de managementgids afgestemd op managers, titels in het Nederlands,
ziekenhuisnamen (UZ Gent, AZORG), labels (k)/(n)/(o), taalfouten; voettekst 41 patient -> patient
met trema; fidelity 44 met protocolnummer, Visitenummer, ulcuspreventie; eCRF 39 alleen opmerkingen
(nieuw: kleine tekstpunten en timing interviews). Deck: titel interviews, term therapeuten, volgorde
deel 1, inhoud hoofdstukdia's, matrix (eCRF 41 en 42), notities.

Co-Authored-By: Claude Opus 5.5 <noreply@anthropic.com>
</commit_message>
<xml_diff>
--- a/PARADISE_presentatie/PARADISE_procesevaluatie_gezondheidseconomie.pptx
+++ b/PARADISE_presentatie/PARADISE_procesevaluatie_gezondheidseconomie.pptx
@@ -1147,7 +1147,7 @@
           <a:lstStyle/>
           <a:p>
             <a:r>
-              <a:t>Deel 1, de procesevaluatie: drie vragen, de bronnen die ze beantwoorden, en wat uw team daarvoor doet.</a:t>
+              <a:t>Deel 1, de procesevaluatie: drie vragen en hun bronnen, de interviews en de fideliteit, en wat uw team daarvoor doet.</a:t>
             </a:r>
           </a:p>
         </p:txBody>
@@ -1287,7 +1287,7 @@
           <a:lstStyle/>
           <a:p>
             <a:r>
-              <a:t>Dit is het protocol van de procesevaluatie in één beeld. De implementatie halen we uit alle vijf de bronnen. Voor de werkingsmechanismen leunen we op de interviews en op wat de studie toch al verzamelt, zoals de therapietrouw en de ongewenste voorvallen. De context komt uit de interviews en de community of practice. Wat betekent dat concreet voor uw team?</a:t>
+              <a:t>Dit is het protocol van de procesevaluatie in één beeld. De implementatie halen we uit alle vijf de bronnen. Voor de werkingsmechanismen leunen we op de interviews en op wat de studie toch al verzamelt, zoals de vragen naar motivatie en zelfvertrouwen en de ongewenste voorvallen. De context komt uit de interviews en de community of practice. Eerst de interviews.</a:t>
             </a:r>
           </a:p>
         </p:txBody>
@@ -1357,7 +1357,7 @@
           <a:lstStyle/>
           <a:p>
             <a:r>
-              <a:t>Drie dingen. Na elke PARADISE-sessie vult wie de sessie gaf het dagboek in, eCRF 40. Van elke patiënt in Optimal Care worden twee sessies op video opgenomen; welke, wordt willekeurig bepaald, en de patiënt geeft daarvoor afzonderlijk toestemming. Die opnames worden gescoord met de fidelity-checklist. En elke zes maanden komen podologen en pedorthisten samen in de community of practice, om ervaringen en aanpassingen te delen.</a:t>
+              <a:t>Daarnaast de interviews. Zestien patiënten, binnen twee maanden na hun laatste PARADISE-sessie. Zestien therapeuten, tussentijds om de zes maanden en op het einde; zo’n interview duurt 60 tot 90 minuten. En op het einde van de studie de lokale hoofdonderzoeker en wie het zorgpad coördineert. Alles wordt opgenomen, uitgeschreven en gepseudonimiseerd, en zowel deductief als inductief geanalyseerd. Dan de fideliteit.</a:t>
             </a:r>
           </a:p>
         </p:txBody>
@@ -1427,7 +1427,7 @@
           <a:lstStyle/>
           <a:p>
             <a:r>
-              <a:t>Daarnaast de interviews. Zestien patiënten, binnen twee maanden na hun laatste PARADISE-sessie. Zestien zorgverleners, tussentijds om de zes maanden en op het einde; zo een interview duurt 60 tot 90 minuten. En op het einde van de studie de lokale hoofdonderzoeker en wie het zorgpad coördineert. Alles wordt opgenomen, uitgeschreven en gepseudonimiseerd, en zowel deductief als inductief geanalyseerd.</a:t>
+              <a:t>Fideliteit betekent: wordt PARADISE gegeven zoals bedoeld? Elk onderdeel van het SEBIA-script krijgt een score: niet, gedeeltelijk of volledig uitgevoerd. Daarnaast de didactiek, de basisvaardigheden van motiverende gespreksvoering, en of de deelnemer de kernboodschappen zelf kan navertellen. Dat scoren gebeurt uit de video-opnames, per visite voor de onderdelen van die visite. Wat betekent dat concreet voor uw team?</a:t>
             </a:r>
           </a:p>
         </p:txBody>
@@ -1497,7 +1497,7 @@
           <a:lstStyle/>
           <a:p>
             <a:r>
-              <a:t>Fideliteit betekent: wordt PARADISE gegeven zoals bedoeld? Elk onderdeel van het SEBIA-script krijgt een score: niet, gedeeltelijk of volledig uitgevoerd. Daarnaast de didactiek, de basisvaardigheden van motiverende gespreksvoering, en of de deelnemer de kernboodschappen zelf kan navertellen. Per visite zijn dat de onderdelen van die visite.</a:t>
+              <a:t>Drie dingen. Na elke PARADISE-sessie vult wie de sessie gaf het dagboek in, eCRF 40. Van elke patiënt in Optimal Care worden twee sessies op video opgenomen; welke, wordt willekeurig bepaald, en de patiënt geeft daarvoor afzonderlijk toestemming. Die opnames worden gescoord met de fidelity-checklist. En elke zes maanden komen podologen en pedorthisten samen in de community of practice, om ervaringen en aanpassingen te delen. Tot slot: wie evalueert welk centrum.</a:t>
             </a:r>
           </a:p>
         </p:txBody>
@@ -1567,7 +1567,7 @@
           <a:lstStyle/>
           <a:p>
             <a:r>
-              <a:t>Om de evaluatie onafhankelijk te houden, wisselen de doctorandi van rol. Wie uw contactpersoon is, evalueert een ander centrum. Janou De Buyser is contactpersoon voor Brugge, Gent en Kortrijk, en evalueert Leuven, Aalst en Antwerpen. De tweede doctorandus, die nog aangeworven wordt, doet het omgekeerde. Daarmee is deel 1 rond.</a:t>
+              <a:t>Om de evaluatie onafhankelijk te houden, wisselen de doctorandi van rol. Wie uw contactpersoon is, evalueert een ander centrum. Janou De Buyser is contactpersoon voor Brugge, Gent en Kortrijk, en evalueert Leuven, Aalst en Antwerpen. De tweede doctorandus, die nog geselecteerd wordt, doet het omgekeerde. Daarmee is deel 1 rond.</a:t>
             </a:r>
           </a:p>
         </p:txBody>
@@ -6040,7 +6040,7 @@
                 </a:solidFill>
                 <a:latin typeface="DM Sans"/>
               </a:rPr>
-              <a:t>wat uw team doet</a:t>
+              <a:t>tijd per visite (eCRF 49)</a:t>
             </a:r>
           </a:p>
         </p:txBody>
@@ -12924,7 +12924,7 @@
                 </a:solidFill>
                 <a:latin typeface="DM Sans"/>
               </a:rPr>
-              <a:t>de bronnen en de interviews</a:t>
+              <a:t>interviews en fideliteit</a:t>
             </a:r>
           </a:p>
         </p:txBody>
@@ -14359,7 +14359,7 @@
                 </a:solidFill>
                 <a:latin typeface="DM Sans"/>
               </a:rPr>
-              <a:t>eCRF 41–43</a:t>
+              <a:t>eCRF 41 en 42</a:t>
             </a:r>
           </a:p>
         </p:txBody>
@@ -15517,7 +15517,7 @@
                 </a:solidFill>
                 <a:latin typeface="DM Serif Display"/>
               </a:rPr>
-              <a:t>Wat uw team doet voor de procesevaluatie</a:t>
+              <a:t>Interviews: drie groepen, elk op hun eigen moment</a:t>
             </a:r>
           </a:p>
         </p:txBody>
@@ -15625,7 +15625,7 @@
                 </a:solidFill>
                 <a:latin typeface="DM Sans"/>
               </a:rPr>
-              <a:t>Bron: eCRF 39 · eCRF 40 en 44 · toestemmingsformulier patiënt (eCRF 02)</a:t>
+              <a:t>Bron: eCRF 39 · protocol §5.2.3 en §5.2.4 · eCRF 04 en 05</a:t>
             </a:r>
           </a:p>
         </p:txBody>
@@ -15639,14 +15639,14 @@
         <p:spPr>
           <a:xfrm>
             <a:off x="812800" y="2095500"/>
-            <a:ext cx="10566400" cy="0"/>
+            <a:ext cx="3302000" cy="0"/>
           </a:xfrm>
           <a:prstGeom prst="line">
             <a:avLst/>
           </a:prstGeom>
-          <a:ln w="6350">
+          <a:ln w="19050">
             <a:solidFill>
-              <a:srgbClr val="D3DFE8"/>
+              <a:srgbClr val="0B6E8F"/>
             </a:solidFill>
           </a:ln>
         </p:spPr>
@@ -15674,7 +15674,7 @@
         <p:spPr>
           <a:xfrm>
             <a:off x="812800" y="2260600"/>
-            <a:ext cx="2984500" cy="571500"/>
+            <a:ext cx="3302000" cy="381000"/>
           </a:xfrm>
           <a:prstGeom prst="rect">
             <a:avLst/>
@@ -15696,13 +15696,13 @@
               </a:spcAft>
             </a:pPr>
             <a:r>
-              <a:rPr sz="1954" b="0" i="0">
-                <a:solidFill>
-                  <a:srgbClr val="A34A00"/>
+              <a:rPr sz="2529" b="0" i="0">
+                <a:solidFill>
+                  <a:srgbClr val="0A2540"/>
                 </a:solidFill>
                 <a:latin typeface="DM Serif Display"/>
               </a:rPr>
-              <a:t>Na elke sessie</a:t>
+              <a:t>Patiënten</a:t>
             </a:r>
           </a:p>
         </p:txBody>
@@ -15715,8 +15715,8 @@
         </p:nvSpPr>
         <p:spPr>
           <a:xfrm>
-            <a:off x="4064000" y="2273300"/>
-            <a:ext cx="5715000" cy="698500"/>
+            <a:off x="812800" y="2667000"/>
+            <a:ext cx="3302000" cy="228600"/>
           </a:xfrm>
           <a:prstGeom prst="rect">
             <a:avLst/>
@@ -15738,103 +15738,97 @@
               </a:spcAft>
             </a:pPr>
             <a:r>
-              <a:rPr sz="1725" b="0" i="0">
+              <a:rPr sz="1380" b="0" i="0">
+                <a:solidFill>
+                  <a:srgbClr val="5A6E80"/>
+                </a:solidFill>
+                <a:latin typeface="DM Sans"/>
+              </a:rPr>
+              <a:t>eCRF 41</a:t>
+            </a:r>
+          </a:p>
+        </p:txBody>
+      </p:sp>
+      <p:sp>
+        <p:nvSpPr>
+          <p:cNvPr id="10" name="TextBox 9"/>
+          <p:cNvSpPr txBox="1"/>
+          <p:nvPr/>
+        </p:nvSpPr>
+        <p:spPr>
+          <a:xfrm>
+            <a:off x="812800" y="3048000"/>
+            <a:ext cx="3302000" cy="762000"/>
+          </a:xfrm>
+          <a:prstGeom prst="rect">
+            <a:avLst/>
+          </a:prstGeom>
+          <a:noFill/>
+        </p:spPr>
+        <p:txBody>
+          <a:bodyPr wrap="square" lIns="0" rIns="0" tIns="0" bIns="0" anchor="t">
+            <a:spAutoFit/>
+          </a:bodyPr>
+          <a:lstStyle/>
+          <a:p>
+            <a:pPr algn="l">
+              <a:lnSpc>
+                <a:spcPct val="100000"/>
+              </a:lnSpc>
+              <a:spcAft>
+                <a:spcPts val="0"/>
+              </a:spcAft>
+            </a:pPr>
+            <a:r>
+              <a:rPr sz="4800" b="0" i="0">
+                <a:solidFill>
+                  <a:srgbClr val="0B6E8F"/>
+                </a:solidFill>
+                <a:latin typeface="DM Serif Display"/>
+              </a:rPr>
+              <a:t>16</a:t>
+            </a:r>
+          </a:p>
+        </p:txBody>
+      </p:sp>
+      <p:sp>
+        <p:nvSpPr>
+          <p:cNvPr id="11" name="TextBox 10"/>
+          <p:cNvSpPr txBox="1"/>
+          <p:nvPr/>
+        </p:nvSpPr>
+        <p:spPr>
+          <a:xfrm>
+            <a:off x="812800" y="4000500"/>
+            <a:ext cx="3302000" cy="762000"/>
+          </a:xfrm>
+          <a:prstGeom prst="rect">
+            <a:avLst/>
+          </a:prstGeom>
+          <a:noFill/>
+        </p:spPr>
+        <p:txBody>
+          <a:bodyPr wrap="square" lIns="0" rIns="0" tIns="0" bIns="0" anchor="t">
+            <a:spAutoFit/>
+          </a:bodyPr>
+          <a:lstStyle/>
+          <a:p>
+            <a:pPr algn="l">
+              <a:lnSpc>
+                <a:spcPct val="125000"/>
+              </a:lnSpc>
+              <a:spcAft>
+                <a:spcPts val="0"/>
+              </a:spcAft>
+            </a:pPr>
+            <a:r>
+              <a:rPr sz="1609" b="0" i="0">
                 <a:solidFill>
                   <a:srgbClr val="3A4F63"/>
                 </a:solidFill>
                 <a:latin typeface="DM Sans"/>
               </a:rPr>
-              <a:t>Het dagboek invullen (eCRF 40)</a:t>
-            </a:r>
-          </a:p>
-        </p:txBody>
-      </p:sp>
-      <p:sp>
-        <p:nvSpPr>
-          <p:cNvPr id="10" name="Rounded Rectangle 9"/>
-          <p:cNvSpPr/>
-          <p:nvPr/>
-        </p:nvSpPr>
-        <p:spPr>
-          <a:xfrm>
-            <a:off x="9677400" y="2247900"/>
-            <a:ext cx="1701800" cy="355600"/>
-          </a:xfrm>
-          <a:prstGeom prst="roundRect">
-            <a:avLst>
-              <a:gd name="adj" fmla="val 50000"/>
-            </a:avLst>
-          </a:prstGeom>
-          <a:solidFill>
-            <a:srgbClr val="FFFFFF"/>
-          </a:solidFill>
-          <a:ln w="15875">
-            <a:solidFill>
-              <a:srgbClr val="0B6E8F"/>
-            </a:solidFill>
-          </a:ln>
-          <a:effectLst/>
-        </p:spPr>
-        <p:style>
-          <a:lnRef idx="1">
-            <a:schemeClr val="accent1"/>
-          </a:lnRef>
-          <a:fillRef idx="3">
-            <a:schemeClr val="accent1"/>
-          </a:fillRef>
-          <a:effectRef idx="2">
-            <a:schemeClr val="accent1"/>
-          </a:effectRef>
-          <a:fontRef idx="minor">
-            <a:schemeClr val="lt1"/>
-          </a:fontRef>
-        </p:style>
-        <p:txBody>
-          <a:bodyPr rtlCol="0" anchor="ctr"/>
-          <a:lstStyle/>
-          <a:p>
-            <a:pPr algn="ctr"/>
-          </a:p>
-        </p:txBody>
-      </p:sp>
-      <p:sp>
-        <p:nvSpPr>
-          <p:cNvPr id="11" name="TextBox 10"/>
-          <p:cNvSpPr txBox="1"/>
-          <p:nvPr/>
-        </p:nvSpPr>
-        <p:spPr>
-          <a:xfrm>
-            <a:off x="9677400" y="2305050"/>
-            <a:ext cx="1701800" cy="254000"/>
-          </a:xfrm>
-          <a:prstGeom prst="rect">
-            <a:avLst/>
-          </a:prstGeom>
-          <a:noFill/>
-        </p:spPr>
-        <p:txBody>
-          <a:bodyPr wrap="square" lIns="0" rIns="0" tIns="0" bIns="0" anchor="t">
-            <a:spAutoFit/>
-          </a:bodyPr>
-          <a:lstStyle/>
-          <a:p>
-            <a:pPr algn="ctr">
-              <a:lnSpc>
-                <a:spcPct val="125000"/>
-              </a:lnSpc>
-              <a:spcAft>
-                <a:spcPts val="0"/>
-              </a:spcAft>
-            </a:pPr>
-            <a:r>
-              <a:rPr sz="1500" b="1" i="0">
-                <a:solidFill>
-                  <a:srgbClr val="0B6E8F"/>
-                </a:solidFill>
-                <a:latin typeface="DM Sans"/>
-              </a:rPr>
-              <a:t>Optimal Care</a:t>
+              <a:t>tot twee maanden na de laatste PARADISE-sessie</a:t>
             </a:r>
           </a:p>
         </p:txBody>
@@ -15847,15 +15841,15 @@
         </p:nvCxnSpPr>
         <p:spPr>
           <a:xfrm>
-            <a:off x="812800" y="3048000"/>
-            <a:ext cx="10566400" cy="0"/>
+            <a:off x="4419600" y="2095500"/>
+            <a:ext cx="3302000" cy="0"/>
           </a:xfrm>
           <a:prstGeom prst="line">
             <a:avLst/>
           </a:prstGeom>
-          <a:ln w="6350">
+          <a:ln w="19050">
             <a:solidFill>
-              <a:srgbClr val="D3DFE8"/>
+              <a:srgbClr val="0B6E8F"/>
             </a:solidFill>
           </a:ln>
         </p:spPr>
@@ -15882,8 +15876,8 @@
         </p:nvSpPr>
         <p:spPr>
           <a:xfrm>
-            <a:off x="812800" y="3213100"/>
-            <a:ext cx="2984500" cy="571500"/>
+            <a:off x="4419600" y="2260600"/>
+            <a:ext cx="3302000" cy="381000"/>
           </a:xfrm>
           <a:prstGeom prst="rect">
             <a:avLst/>
@@ -15905,13 +15899,13 @@
               </a:spcAft>
             </a:pPr>
             <a:r>
-              <a:rPr sz="1954" b="0" i="0">
-                <a:solidFill>
-                  <a:srgbClr val="A34A00"/>
+              <a:rPr sz="2529" b="0" i="0">
+                <a:solidFill>
+                  <a:srgbClr val="0A2540"/>
                 </a:solidFill>
                 <a:latin typeface="DM Serif Display"/>
               </a:rPr>
-              <a:t>Twee sessies per patiënt</a:t>
+              <a:t>Therapeuten</a:t>
             </a:r>
           </a:p>
         </p:txBody>
@@ -15924,8 +15918,8 @@
         </p:nvSpPr>
         <p:spPr>
           <a:xfrm>
-            <a:off x="4064000" y="3225800"/>
-            <a:ext cx="5715000" cy="698500"/>
+            <a:off x="4419600" y="2667000"/>
+            <a:ext cx="3302000" cy="228600"/>
           </a:xfrm>
           <a:prstGeom prst="rect">
             <a:avLst/>
@@ -15947,103 +15941,97 @@
               </a:spcAft>
             </a:pPr>
             <a:r>
-              <a:rPr sz="1725" b="0" i="0">
+              <a:rPr sz="1380" b="0" i="0">
+                <a:solidFill>
+                  <a:srgbClr val="5A6E80"/>
+                </a:solidFill>
+                <a:latin typeface="DM Sans"/>
+              </a:rPr>
+              <a:t>eCRF 42</a:t>
+            </a:r>
+          </a:p>
+        </p:txBody>
+      </p:sp>
+      <p:sp>
+        <p:nvSpPr>
+          <p:cNvPr id="15" name="TextBox 14"/>
+          <p:cNvSpPr txBox="1"/>
+          <p:nvPr/>
+        </p:nvSpPr>
+        <p:spPr>
+          <a:xfrm>
+            <a:off x="4419600" y="3048000"/>
+            <a:ext cx="3302000" cy="762000"/>
+          </a:xfrm>
+          <a:prstGeom prst="rect">
+            <a:avLst/>
+          </a:prstGeom>
+          <a:noFill/>
+        </p:spPr>
+        <p:txBody>
+          <a:bodyPr wrap="square" lIns="0" rIns="0" tIns="0" bIns="0" anchor="t">
+            <a:spAutoFit/>
+          </a:bodyPr>
+          <a:lstStyle/>
+          <a:p>
+            <a:pPr algn="l">
+              <a:lnSpc>
+                <a:spcPct val="100000"/>
+              </a:lnSpc>
+              <a:spcAft>
+                <a:spcPts val="0"/>
+              </a:spcAft>
+            </a:pPr>
+            <a:r>
+              <a:rPr sz="4800" b="0" i="0">
+                <a:solidFill>
+                  <a:srgbClr val="0B6E8F"/>
+                </a:solidFill>
+                <a:latin typeface="DM Serif Display"/>
+              </a:rPr>
+              <a:t>16</a:t>
+            </a:r>
+          </a:p>
+        </p:txBody>
+      </p:sp>
+      <p:sp>
+        <p:nvSpPr>
+          <p:cNvPr id="16" name="TextBox 15"/>
+          <p:cNvSpPr txBox="1"/>
+          <p:nvPr/>
+        </p:nvSpPr>
+        <p:spPr>
+          <a:xfrm>
+            <a:off x="4419600" y="4000500"/>
+            <a:ext cx="3302000" cy="762000"/>
+          </a:xfrm>
+          <a:prstGeom prst="rect">
+            <a:avLst/>
+          </a:prstGeom>
+          <a:noFill/>
+        </p:spPr>
+        <p:txBody>
+          <a:bodyPr wrap="square" lIns="0" rIns="0" tIns="0" bIns="0" anchor="t">
+            <a:spAutoFit/>
+          </a:bodyPr>
+          <a:lstStyle/>
+          <a:p>
+            <a:pPr algn="l">
+              <a:lnSpc>
+                <a:spcPct val="125000"/>
+              </a:lnSpc>
+              <a:spcAft>
+                <a:spcPts val="0"/>
+              </a:spcAft>
+            </a:pPr>
+            <a:r>
+              <a:rPr sz="1609" b="0" i="0">
                 <a:solidFill>
                   <a:srgbClr val="3A4F63"/>
                 </a:solidFill>
                 <a:latin typeface="DM Sans"/>
               </a:rPr>
-              <a:t>Op video, willekeurig gekozen, en gescoord met de fidelity-checklist (eCRF 44)</a:t>
-            </a:r>
-          </a:p>
-        </p:txBody>
-      </p:sp>
-      <p:sp>
-        <p:nvSpPr>
-          <p:cNvPr id="15" name="Rounded Rectangle 14"/>
-          <p:cNvSpPr/>
-          <p:nvPr/>
-        </p:nvSpPr>
-        <p:spPr>
-          <a:xfrm>
-            <a:off x="9677400" y="3200400"/>
-            <a:ext cx="1701800" cy="355600"/>
-          </a:xfrm>
-          <a:prstGeom prst="roundRect">
-            <a:avLst>
-              <a:gd name="adj" fmla="val 50000"/>
-            </a:avLst>
-          </a:prstGeom>
-          <a:solidFill>
-            <a:srgbClr val="FFFFFF"/>
-          </a:solidFill>
-          <a:ln w="15875">
-            <a:solidFill>
-              <a:srgbClr val="0B6E8F"/>
-            </a:solidFill>
-          </a:ln>
-          <a:effectLst/>
-        </p:spPr>
-        <p:style>
-          <a:lnRef idx="1">
-            <a:schemeClr val="accent1"/>
-          </a:lnRef>
-          <a:fillRef idx="3">
-            <a:schemeClr val="accent1"/>
-          </a:fillRef>
-          <a:effectRef idx="2">
-            <a:schemeClr val="accent1"/>
-          </a:effectRef>
-          <a:fontRef idx="minor">
-            <a:schemeClr val="lt1"/>
-          </a:fontRef>
-        </p:style>
-        <p:txBody>
-          <a:bodyPr rtlCol="0" anchor="ctr"/>
-          <a:lstStyle/>
-          <a:p>
-            <a:pPr algn="ctr"/>
-          </a:p>
-        </p:txBody>
-      </p:sp>
-      <p:sp>
-        <p:nvSpPr>
-          <p:cNvPr id="16" name="TextBox 15"/>
-          <p:cNvSpPr txBox="1"/>
-          <p:nvPr/>
-        </p:nvSpPr>
-        <p:spPr>
-          <a:xfrm>
-            <a:off x="9677400" y="3257550"/>
-            <a:ext cx="1701800" cy="254000"/>
-          </a:xfrm>
-          <a:prstGeom prst="rect">
-            <a:avLst/>
-          </a:prstGeom>
-          <a:noFill/>
-        </p:spPr>
-        <p:txBody>
-          <a:bodyPr wrap="square" lIns="0" rIns="0" tIns="0" bIns="0" anchor="t">
-            <a:spAutoFit/>
-          </a:bodyPr>
-          <a:lstStyle/>
-          <a:p>
-            <a:pPr algn="ctr">
-              <a:lnSpc>
-                <a:spcPct val="125000"/>
-              </a:lnSpc>
-              <a:spcAft>
-                <a:spcPts val="0"/>
-              </a:spcAft>
-            </a:pPr>
-            <a:r>
-              <a:rPr sz="1500" b="1" i="0">
-                <a:solidFill>
-                  <a:srgbClr val="0B6E8F"/>
-                </a:solidFill>
-                <a:latin typeface="DM Sans"/>
-              </a:rPr>
-              <a:t>Optimal Care</a:t>
+              <a:t>elke zes maanden en op het einde · 60 tot 90 minuten</a:t>
             </a:r>
           </a:p>
         </p:txBody>
@@ -16056,15 +16044,15 @@
         </p:nvCxnSpPr>
         <p:spPr>
           <a:xfrm>
-            <a:off x="812800" y="4000500"/>
-            <a:ext cx="10566400" cy="0"/>
+            <a:off x="8026400" y="2095500"/>
+            <a:ext cx="3302000" cy="0"/>
           </a:xfrm>
           <a:prstGeom prst="line">
             <a:avLst/>
           </a:prstGeom>
-          <a:ln w="6350">
+          <a:ln w="19050">
             <a:solidFill>
-              <a:srgbClr val="D3DFE8"/>
+              <a:srgbClr val="0B6E8F"/>
             </a:solidFill>
           </a:ln>
         </p:spPr>
@@ -16091,8 +16079,8 @@
         </p:nvSpPr>
         <p:spPr>
           <a:xfrm>
-            <a:off x="812800" y="4165600"/>
-            <a:ext cx="2984500" cy="571500"/>
+            <a:off x="8026400" y="2260600"/>
+            <a:ext cx="3302000" cy="381000"/>
           </a:xfrm>
           <a:prstGeom prst="rect">
             <a:avLst/>
@@ -16114,13 +16102,13 @@
               </a:spcAft>
             </a:pPr>
             <a:r>
-              <a:rPr sz="1954" b="0" i="0">
-                <a:solidFill>
-                  <a:srgbClr val="A34A00"/>
+              <a:rPr sz="2529" b="0" i="0">
+                <a:solidFill>
+                  <a:srgbClr val="0A2540"/>
                 </a:solidFill>
                 <a:latin typeface="DM Serif Display"/>
               </a:rPr>
-              <a:t>Elke zes maanden</a:t>
+              <a:t>Management</a:t>
             </a:r>
           </a:p>
         </p:txBody>
@@ -16133,8 +16121,8 @@
         </p:nvSpPr>
         <p:spPr>
           <a:xfrm>
-            <a:off x="4064000" y="4178300"/>
-            <a:ext cx="7302500" cy="698500"/>
+            <a:off x="8026400" y="2667000"/>
+            <a:ext cx="3302000" cy="228600"/>
           </a:xfrm>
           <a:prstGeom prst="rect">
             <a:avLst/>
@@ -16156,26 +16144,110 @@
               </a:spcAft>
             </a:pPr>
             <a:r>
-              <a:rPr sz="1725" b="0" i="0">
+              <a:rPr sz="1380" b="0" i="0">
+                <a:solidFill>
+                  <a:srgbClr val="5A6E80"/>
+                </a:solidFill>
+                <a:latin typeface="DM Sans"/>
+              </a:rPr>
+              <a:t>eCRF 43</a:t>
+            </a:r>
+          </a:p>
+        </p:txBody>
+      </p:sp>
+      <p:sp>
+        <p:nvSpPr>
+          <p:cNvPr id="20" name="TextBox 19"/>
+          <p:cNvSpPr txBox="1"/>
+          <p:nvPr/>
+        </p:nvSpPr>
+        <p:spPr>
+          <a:xfrm>
+            <a:off x="8026400" y="3048000"/>
+            <a:ext cx="3302000" cy="762000"/>
+          </a:xfrm>
+          <a:prstGeom prst="rect">
+            <a:avLst/>
+          </a:prstGeom>
+          <a:noFill/>
+        </p:spPr>
+        <p:txBody>
+          <a:bodyPr wrap="square" lIns="0" rIns="0" tIns="0" bIns="0" anchor="t">
+            <a:spAutoFit/>
+          </a:bodyPr>
+          <a:lstStyle/>
+          <a:p>
+            <a:pPr algn="l">
+              <a:lnSpc>
+                <a:spcPct val="100000"/>
+              </a:lnSpc>
+              <a:spcAft>
+                <a:spcPts val="0"/>
+              </a:spcAft>
+            </a:pPr>
+            <a:r>
+              <a:rPr sz="2990" b="0" i="0">
+                <a:solidFill>
+                  <a:srgbClr val="0B6E8F"/>
+                </a:solidFill>
+                <a:latin typeface="DM Serif Display"/>
+              </a:rPr>
+              <a:t>PI + coördinator</a:t>
+            </a:r>
+          </a:p>
+        </p:txBody>
+      </p:sp>
+      <p:sp>
+        <p:nvSpPr>
+          <p:cNvPr id="21" name="TextBox 20"/>
+          <p:cNvSpPr txBox="1"/>
+          <p:nvPr/>
+        </p:nvSpPr>
+        <p:spPr>
+          <a:xfrm>
+            <a:off x="8026400" y="4000500"/>
+            <a:ext cx="3302000" cy="762000"/>
+          </a:xfrm>
+          <a:prstGeom prst="rect">
+            <a:avLst/>
+          </a:prstGeom>
+          <a:noFill/>
+        </p:spPr>
+        <p:txBody>
+          <a:bodyPr wrap="square" lIns="0" rIns="0" tIns="0" bIns="0" anchor="t">
+            <a:spAutoFit/>
+          </a:bodyPr>
+          <a:lstStyle/>
+          <a:p>
+            <a:pPr algn="l">
+              <a:lnSpc>
+                <a:spcPct val="125000"/>
+              </a:lnSpc>
+              <a:spcAft>
+                <a:spcPts val="0"/>
+              </a:spcAft>
+            </a:pPr>
+            <a:r>
+              <a:rPr sz="1609" b="0" i="0">
                 <a:solidFill>
                   <a:srgbClr val="3A4F63"/>
                 </a:solidFill>
                 <a:latin typeface="DM Sans"/>
               </a:rPr>
-              <a:t>Community of practice: podologen en pedorthisten delen ervaringen en aanpassingen</a:t>
+              <a:t>op het einde van de studie · 60 tot 90 minuten</a:t>
             </a:r>
           </a:p>
         </p:txBody>
       </p:sp>
       <p:cxnSp>
         <p:nvCxnSpPr>
-          <p:cNvPr id="20" name="Connector 19"/>
+          <p:cNvPr id="22" name="Connector 21"/>
           <p:cNvCxnSpPr/>
           <p:nvPr/>
         </p:nvCxnSpPr>
         <p:spPr>
           <a:xfrm>
-            <a:off x="812800" y="4953000"/>
+            <a:off x="812800" y="5080000"/>
             <a:ext cx="10566400" cy="0"/>
           </a:xfrm>
           <a:prstGeom prst="line">
@@ -16315,7 +16387,7 @@
                 </a:solidFill>
                 <a:latin typeface="DM Serif Display"/>
               </a:rPr>
-              <a:t>Drie groepen, één gesprek per persoon</a:t>
+              <a:t>Fideliteit: elk scriptonderdeel krijgt een score</a:t>
             </a:r>
           </a:p>
         </p:txBody>
@@ -16423,28 +16495,280 @@
                 </a:solidFill>
                 <a:latin typeface="DM Sans"/>
               </a:rPr>
-              <a:t>Bron: eCRF 39 · protocol §5.2.3 en §5.2.4 · eCRF 04 en 05</a:t>
+              <a:t>Bron: eCRF 44 (fidelity checklist) · eCRF 17 (SEBIA-script)</a:t>
+            </a:r>
+          </a:p>
+        </p:txBody>
+      </p:sp>
+      <p:sp>
+        <p:nvSpPr>
+          <p:cNvPr id="7" name="TextBox 6"/>
+          <p:cNvSpPr txBox="1"/>
+          <p:nvPr/>
+        </p:nvSpPr>
+        <p:spPr>
+          <a:xfrm>
+            <a:off x="812800" y="2095500"/>
+            <a:ext cx="1905000" cy="1270000"/>
+          </a:xfrm>
+          <a:prstGeom prst="rect">
+            <a:avLst/>
+          </a:prstGeom>
+          <a:noFill/>
+        </p:spPr>
+        <p:txBody>
+          <a:bodyPr wrap="square" lIns="0" rIns="0" tIns="0" bIns="0" anchor="t">
+            <a:spAutoFit/>
+          </a:bodyPr>
+          <a:lstStyle/>
+          <a:p>
+            <a:pPr algn="l">
+              <a:lnSpc>
+                <a:spcPct val="90000"/>
+              </a:lnSpc>
+              <a:spcAft>
+                <a:spcPts val="0"/>
+              </a:spcAft>
+            </a:pPr>
+            <a:r>
+              <a:rPr sz="9000" b="0" i="0">
+                <a:solidFill>
+                  <a:srgbClr val="0B6E8F"/>
+                </a:solidFill>
+                <a:latin typeface="DM Serif Display"/>
+              </a:rPr>
+              <a:t>0</a:t>
+            </a:r>
+          </a:p>
+        </p:txBody>
+      </p:sp>
+      <p:sp>
+        <p:nvSpPr>
+          <p:cNvPr id="8" name="TextBox 7"/>
+          <p:cNvSpPr txBox="1"/>
+          <p:nvPr/>
+        </p:nvSpPr>
+        <p:spPr>
+          <a:xfrm>
+            <a:off x="812800" y="3429000"/>
+            <a:ext cx="2095500" cy="317500"/>
+          </a:xfrm>
+          <a:prstGeom prst="rect">
+            <a:avLst/>
+          </a:prstGeom>
+          <a:noFill/>
+        </p:spPr>
+        <p:txBody>
+          <a:bodyPr wrap="square" lIns="0" rIns="0" tIns="0" bIns="0" anchor="t">
+            <a:spAutoFit/>
+          </a:bodyPr>
+          <a:lstStyle/>
+          <a:p>
+            <a:pPr algn="l">
+              <a:lnSpc>
+                <a:spcPct val="125000"/>
+              </a:lnSpc>
+              <a:spcAft>
+                <a:spcPts val="0"/>
+              </a:spcAft>
+            </a:pPr>
+            <a:r>
+              <a:rPr sz="1839" b="0" i="0">
+                <a:solidFill>
+                  <a:srgbClr val="0A2540"/>
+                </a:solidFill>
+                <a:latin typeface="DM Sans"/>
+              </a:rPr>
+              <a:t>niet uitgevoerd</a:t>
+            </a:r>
+          </a:p>
+        </p:txBody>
+      </p:sp>
+      <p:sp>
+        <p:nvSpPr>
+          <p:cNvPr id="9" name="TextBox 8"/>
+          <p:cNvSpPr txBox="1"/>
+          <p:nvPr/>
+        </p:nvSpPr>
+        <p:spPr>
+          <a:xfrm>
+            <a:off x="3225800" y="2095500"/>
+            <a:ext cx="1905000" cy="1270000"/>
+          </a:xfrm>
+          <a:prstGeom prst="rect">
+            <a:avLst/>
+          </a:prstGeom>
+          <a:noFill/>
+        </p:spPr>
+        <p:txBody>
+          <a:bodyPr wrap="square" lIns="0" rIns="0" tIns="0" bIns="0" anchor="t">
+            <a:spAutoFit/>
+          </a:bodyPr>
+          <a:lstStyle/>
+          <a:p>
+            <a:pPr algn="l">
+              <a:lnSpc>
+                <a:spcPct val="90000"/>
+              </a:lnSpc>
+              <a:spcAft>
+                <a:spcPts val="0"/>
+              </a:spcAft>
+            </a:pPr>
+            <a:r>
+              <a:rPr sz="9000" b="0" i="0">
+                <a:solidFill>
+                  <a:srgbClr val="0B6E8F"/>
+                </a:solidFill>
+                <a:latin typeface="DM Serif Display"/>
+              </a:rPr>
+              <a:t>1</a:t>
+            </a:r>
+          </a:p>
+        </p:txBody>
+      </p:sp>
+      <p:sp>
+        <p:nvSpPr>
+          <p:cNvPr id="10" name="TextBox 9"/>
+          <p:cNvSpPr txBox="1"/>
+          <p:nvPr/>
+        </p:nvSpPr>
+        <p:spPr>
+          <a:xfrm>
+            <a:off x="3225800" y="3429000"/>
+            <a:ext cx="2095500" cy="317500"/>
+          </a:xfrm>
+          <a:prstGeom prst="rect">
+            <a:avLst/>
+          </a:prstGeom>
+          <a:noFill/>
+        </p:spPr>
+        <p:txBody>
+          <a:bodyPr wrap="square" lIns="0" rIns="0" tIns="0" bIns="0" anchor="t">
+            <a:spAutoFit/>
+          </a:bodyPr>
+          <a:lstStyle/>
+          <a:p>
+            <a:pPr algn="l">
+              <a:lnSpc>
+                <a:spcPct val="125000"/>
+              </a:lnSpc>
+              <a:spcAft>
+                <a:spcPts val="0"/>
+              </a:spcAft>
+            </a:pPr>
+            <a:r>
+              <a:rPr sz="1839" b="0" i="0">
+                <a:solidFill>
+                  <a:srgbClr val="0A2540"/>
+                </a:solidFill>
+                <a:latin typeface="DM Sans"/>
+              </a:rPr>
+              <a:t>gedeeltelijk</a:t>
+            </a:r>
+          </a:p>
+        </p:txBody>
+      </p:sp>
+      <p:sp>
+        <p:nvSpPr>
+          <p:cNvPr id="11" name="TextBox 10"/>
+          <p:cNvSpPr txBox="1"/>
+          <p:nvPr/>
+        </p:nvSpPr>
+        <p:spPr>
+          <a:xfrm>
+            <a:off x="5638800" y="2095500"/>
+            <a:ext cx="1905000" cy="1270000"/>
+          </a:xfrm>
+          <a:prstGeom prst="rect">
+            <a:avLst/>
+          </a:prstGeom>
+          <a:noFill/>
+        </p:spPr>
+        <p:txBody>
+          <a:bodyPr wrap="square" lIns="0" rIns="0" tIns="0" bIns="0" anchor="t">
+            <a:spAutoFit/>
+          </a:bodyPr>
+          <a:lstStyle/>
+          <a:p>
+            <a:pPr algn="l">
+              <a:lnSpc>
+                <a:spcPct val="90000"/>
+              </a:lnSpc>
+              <a:spcAft>
+                <a:spcPts val="0"/>
+              </a:spcAft>
+            </a:pPr>
+            <a:r>
+              <a:rPr sz="9000" b="0" i="0">
+                <a:solidFill>
+                  <a:srgbClr val="0B6E8F"/>
+                </a:solidFill>
+                <a:latin typeface="DM Serif Display"/>
+              </a:rPr>
+              <a:t>2</a:t>
+            </a:r>
+          </a:p>
+        </p:txBody>
+      </p:sp>
+      <p:sp>
+        <p:nvSpPr>
+          <p:cNvPr id="12" name="TextBox 11"/>
+          <p:cNvSpPr txBox="1"/>
+          <p:nvPr/>
+        </p:nvSpPr>
+        <p:spPr>
+          <a:xfrm>
+            <a:off x="5638800" y="3429000"/>
+            <a:ext cx="2095500" cy="317500"/>
+          </a:xfrm>
+          <a:prstGeom prst="rect">
+            <a:avLst/>
+          </a:prstGeom>
+          <a:noFill/>
+        </p:spPr>
+        <p:txBody>
+          <a:bodyPr wrap="square" lIns="0" rIns="0" tIns="0" bIns="0" anchor="t">
+            <a:spAutoFit/>
+          </a:bodyPr>
+          <a:lstStyle/>
+          <a:p>
+            <a:pPr algn="l">
+              <a:lnSpc>
+                <a:spcPct val="125000"/>
+              </a:lnSpc>
+              <a:spcAft>
+                <a:spcPts val="0"/>
+              </a:spcAft>
+            </a:pPr>
+            <a:r>
+              <a:rPr sz="1839" b="0" i="0">
+                <a:solidFill>
+                  <a:srgbClr val="0A2540"/>
+                </a:solidFill>
+                <a:latin typeface="DM Sans"/>
+              </a:rPr>
+              <a:t>volledig</a:t>
             </a:r>
           </a:p>
         </p:txBody>
       </p:sp>
       <p:cxnSp>
         <p:nvCxnSpPr>
-          <p:cNvPr id="7" name="Connector 6"/>
+          <p:cNvPr id="13" name="Connector 12"/>
           <p:cNvCxnSpPr/>
           <p:nvPr/>
         </p:nvCxnSpPr>
         <p:spPr>
           <a:xfrm>
-            <a:off x="812800" y="2095500"/>
-            <a:ext cx="3302000" cy="0"/>
+            <a:off x="8191500" y="2159000"/>
+            <a:ext cx="0" cy="1905000"/>
           </a:xfrm>
           <a:prstGeom prst="line">
             <a:avLst/>
           </a:prstGeom>
-          <a:ln w="19050">
+          <a:ln w="6350">
             <a:solidFill>
-              <a:srgbClr val="0B6E8F"/>
+              <a:srgbClr val="D3DFE8"/>
             </a:solidFill>
           </a:ln>
         </p:spPr>
@@ -16465,14 +16789,14 @@
       </p:cxnSp>
       <p:sp>
         <p:nvSpPr>
-          <p:cNvPr id="8" name="TextBox 7"/>
-          <p:cNvSpPr txBox="1"/>
-          <p:nvPr/>
-        </p:nvSpPr>
-        <p:spPr>
-          <a:xfrm>
-            <a:off x="812800" y="2260600"/>
-            <a:ext cx="3302000" cy="381000"/>
+          <p:cNvPr id="14" name="TextBox 13"/>
+          <p:cNvSpPr txBox="1"/>
+          <p:nvPr/>
+        </p:nvSpPr>
+        <p:spPr>
+          <a:xfrm>
+            <a:off x="8509000" y="2159000"/>
+            <a:ext cx="2870200" cy="2032000"/>
           </a:xfrm>
           <a:prstGeom prst="rect">
             <a:avLst/>
@@ -16490,133 +16814,64 @@
                 <a:spcPct val="125000"/>
               </a:lnSpc>
               <a:spcAft>
-                <a:spcPts val="0"/>
-              </a:spcAft>
-            </a:pPr>
-            <a:r>
-              <a:rPr sz="2529" b="0" i="0">
-                <a:solidFill>
-                  <a:srgbClr val="0A2540"/>
-                </a:solidFill>
-                <a:latin typeface="DM Serif Display"/>
-              </a:rPr>
-              <a:t>Patiënten</a:t>
-            </a:r>
-          </a:p>
-        </p:txBody>
-      </p:sp>
-      <p:sp>
-        <p:nvSpPr>
-          <p:cNvPr id="9" name="TextBox 8"/>
-          <p:cNvSpPr txBox="1"/>
-          <p:nvPr/>
-        </p:nvSpPr>
-        <p:spPr>
-          <a:xfrm>
-            <a:off x="812800" y="2667000"/>
-            <a:ext cx="3302000" cy="228600"/>
-          </a:xfrm>
-          <a:prstGeom prst="rect">
-            <a:avLst/>
-          </a:prstGeom>
-          <a:noFill/>
-        </p:spPr>
-        <p:txBody>
-          <a:bodyPr wrap="square" lIns="0" rIns="0" tIns="0" bIns="0" anchor="t">
-            <a:spAutoFit/>
-          </a:bodyPr>
-          <a:lstStyle/>
+                <a:spcPts val="400"/>
+              </a:spcAft>
+            </a:pPr>
+            <a:r>
+              <a:rPr sz="1609" b="0" i="0">
+                <a:solidFill>
+                  <a:srgbClr val="3A4F63"/>
+                </a:solidFill>
+                <a:latin typeface="DM Sans"/>
+              </a:rPr>
+              <a:t>Ook gescoord:</a:t>
+            </a:r>
+          </a:p>
           <a:p>
             <a:pPr algn="l">
               <a:lnSpc>
                 <a:spcPct val="125000"/>
               </a:lnSpc>
               <a:spcAft>
-                <a:spcPts val="0"/>
-              </a:spcAft>
-            </a:pPr>
-            <a:r>
-              <a:rPr sz="1380" b="0" i="0">
-                <a:solidFill>
-                  <a:srgbClr val="5A6E80"/>
+                <a:spcPts val="400"/>
+              </a:spcAft>
+            </a:pPr>
+            <a:r>
+              <a:rPr sz="1609" b="0" i="0">
+                <a:solidFill>
+                  <a:srgbClr val="3A4F63"/>
                 </a:solidFill>
                 <a:latin typeface="DM Sans"/>
               </a:rPr>
-              <a:t>eCRF 41</a:t>
-            </a:r>
-          </a:p>
-        </p:txBody>
-      </p:sp>
-      <p:sp>
-        <p:nvSpPr>
-          <p:cNvPr id="10" name="TextBox 9"/>
-          <p:cNvSpPr txBox="1"/>
-          <p:nvPr/>
-        </p:nvSpPr>
-        <p:spPr>
-          <a:xfrm>
-            <a:off x="812800" y="3048000"/>
-            <a:ext cx="3302000" cy="762000"/>
-          </a:xfrm>
-          <a:prstGeom prst="rect">
-            <a:avLst/>
-          </a:prstGeom>
-          <a:noFill/>
-        </p:spPr>
-        <p:txBody>
-          <a:bodyPr wrap="square" lIns="0" rIns="0" tIns="0" bIns="0" anchor="t">
-            <a:spAutoFit/>
-          </a:bodyPr>
-          <a:lstStyle/>
+              <a:t>didactiek</a:t>
+            </a:r>
+          </a:p>
           <a:p>
             <a:pPr algn="l">
               <a:lnSpc>
-                <a:spcPct val="100000"/>
-              </a:lnSpc>
-              <a:spcAft>
-                <a:spcPts val="0"/>
-              </a:spcAft>
-            </a:pPr>
-            <a:r>
-              <a:rPr sz="4800" b="0" i="0">
-                <a:solidFill>
-                  <a:srgbClr val="0B6E8F"/>
-                </a:solidFill>
-                <a:latin typeface="DM Serif Display"/>
-              </a:rPr>
-              <a:t>16</a:t>
-            </a:r>
-          </a:p>
-        </p:txBody>
-      </p:sp>
-      <p:sp>
-        <p:nvSpPr>
-          <p:cNvPr id="11" name="TextBox 10"/>
-          <p:cNvSpPr txBox="1"/>
-          <p:nvPr/>
-        </p:nvSpPr>
-        <p:spPr>
-          <a:xfrm>
-            <a:off x="812800" y="4000500"/>
-            <a:ext cx="3302000" cy="762000"/>
-          </a:xfrm>
-          <a:prstGeom prst="rect">
-            <a:avLst/>
-          </a:prstGeom>
-          <a:noFill/>
-        </p:spPr>
-        <p:txBody>
-          <a:bodyPr wrap="square" lIns="0" rIns="0" tIns="0" bIns="0" anchor="t">
-            <a:spAutoFit/>
-          </a:bodyPr>
-          <a:lstStyle/>
+                <a:spcPct val="125000"/>
+              </a:lnSpc>
+              <a:spcAft>
+                <a:spcPts val="400"/>
+              </a:spcAft>
+            </a:pPr>
+            <a:r>
+              <a:rPr sz="1609" b="0" i="0">
+                <a:solidFill>
+                  <a:srgbClr val="3A4F63"/>
+                </a:solidFill>
+                <a:latin typeface="DM Sans"/>
+              </a:rPr>
+              <a:t>motiverende gespreksvoering</a:t>
+            </a:r>
+          </a:p>
           <a:p>
             <a:pPr algn="l">
               <a:lnSpc>
                 <a:spcPct val="125000"/>
               </a:lnSpc>
               <a:spcAft>
-                <a:spcPts val="0"/>
+                <a:spcPts val="400"/>
               </a:spcAft>
             </a:pPr>
             <a:r>
@@ -16626,28 +16881,28 @@
                 </a:solidFill>
                 <a:latin typeface="DM Sans"/>
               </a:rPr>
-              <a:t>tot twee maanden na de laatste PARADISE-sessie</a:t>
+              <a:t>wat de deelnemer kan navertellen</a:t>
             </a:r>
           </a:p>
         </p:txBody>
       </p:sp>
       <p:cxnSp>
         <p:nvCxnSpPr>
-          <p:cNvPr id="12" name="Connector 11"/>
+          <p:cNvPr id="15" name="Connector 14"/>
           <p:cNvCxnSpPr/>
           <p:nvPr/>
         </p:nvCxnSpPr>
         <p:spPr>
           <a:xfrm>
-            <a:off x="4419600" y="2095500"/>
-            <a:ext cx="3302000" cy="0"/>
+            <a:off x="812800" y="4445000"/>
+            <a:ext cx="10566400" cy="0"/>
           </a:xfrm>
           <a:prstGeom prst="line">
             <a:avLst/>
           </a:prstGeom>
-          <a:ln w="19050">
+          <a:ln w="6350">
             <a:solidFill>
-              <a:srgbClr val="0B6E8F"/>
+              <a:srgbClr val="D3DFE8"/>
             </a:solidFill>
           </a:ln>
         </p:spPr>
@@ -16668,14 +16923,14 @@
       </p:cxnSp>
       <p:sp>
         <p:nvSpPr>
-          <p:cNvPr id="13" name="TextBox 12"/>
-          <p:cNvSpPr txBox="1"/>
-          <p:nvPr/>
-        </p:nvSpPr>
-        <p:spPr>
-          <a:xfrm>
-            <a:off x="4419600" y="2260600"/>
-            <a:ext cx="3302000" cy="381000"/>
+          <p:cNvPr id="16" name="TextBox 15"/>
+          <p:cNvSpPr txBox="1"/>
+          <p:nvPr/>
+        </p:nvSpPr>
+        <p:spPr>
+          <a:xfrm>
+            <a:off x="812800" y="4597400"/>
+            <a:ext cx="10566400" cy="317500"/>
           </a:xfrm>
           <a:prstGeom prst="rect">
             <a:avLst/>
@@ -16697,381 +16952,17 @@
               </a:spcAft>
             </a:pPr>
             <a:r>
-              <a:rPr sz="2529" b="0" i="0">
-                <a:solidFill>
-                  <a:srgbClr val="0A2540"/>
-                </a:solidFill>
-                <a:latin typeface="DM Serif Display"/>
-              </a:rPr>
-              <a:t>Zorgverleners</a:t>
-            </a:r>
-          </a:p>
-        </p:txBody>
-      </p:sp>
-      <p:sp>
-        <p:nvSpPr>
-          <p:cNvPr id="14" name="TextBox 13"/>
-          <p:cNvSpPr txBox="1"/>
-          <p:nvPr/>
-        </p:nvSpPr>
-        <p:spPr>
-          <a:xfrm>
-            <a:off x="4419600" y="2667000"/>
-            <a:ext cx="3302000" cy="228600"/>
-          </a:xfrm>
-          <a:prstGeom prst="rect">
-            <a:avLst/>
-          </a:prstGeom>
-          <a:noFill/>
-        </p:spPr>
-        <p:txBody>
-          <a:bodyPr wrap="square" lIns="0" rIns="0" tIns="0" bIns="0" anchor="t">
-            <a:spAutoFit/>
-          </a:bodyPr>
-          <a:lstStyle/>
-          <a:p>
-            <a:pPr algn="l">
-              <a:lnSpc>
-                <a:spcPct val="125000"/>
-              </a:lnSpc>
-              <a:spcAft>
-                <a:spcPts val="0"/>
-              </a:spcAft>
-            </a:pPr>
-            <a:r>
-              <a:rPr sz="1380" b="0" i="0">
-                <a:solidFill>
-                  <a:srgbClr val="5A6E80"/>
+              <a:rPr sz="1725" b="0" i="0">
+                <a:solidFill>
+                  <a:srgbClr val="3A4F63"/>
                 </a:solidFill>
                 <a:latin typeface="DM Sans"/>
               </a:rPr>
-              <a:t>eCRF 42</a:t>
-            </a:r>
-          </a:p>
-        </p:txBody>
-      </p:sp>
-      <p:sp>
-        <p:nvSpPr>
-          <p:cNvPr id="15" name="TextBox 14"/>
-          <p:cNvSpPr txBox="1"/>
-          <p:nvPr/>
-        </p:nvSpPr>
-        <p:spPr>
-          <a:xfrm>
-            <a:off x="4419600" y="3048000"/>
-            <a:ext cx="3302000" cy="762000"/>
-          </a:xfrm>
-          <a:prstGeom prst="rect">
-            <a:avLst/>
-          </a:prstGeom>
-          <a:noFill/>
-        </p:spPr>
-        <p:txBody>
-          <a:bodyPr wrap="square" lIns="0" rIns="0" tIns="0" bIns="0" anchor="t">
-            <a:spAutoFit/>
-          </a:bodyPr>
-          <a:lstStyle/>
-          <a:p>
-            <a:pPr algn="l">
-              <a:lnSpc>
-                <a:spcPct val="100000"/>
-              </a:lnSpc>
-              <a:spcAft>
-                <a:spcPts val="0"/>
-              </a:spcAft>
-            </a:pPr>
-            <a:r>
-              <a:rPr sz="4800" b="0" i="0">
-                <a:solidFill>
-                  <a:srgbClr val="0B6E8F"/>
-                </a:solidFill>
-                <a:latin typeface="DM Serif Display"/>
-              </a:rPr>
-              <a:t>16</a:t>
-            </a:r>
-          </a:p>
-        </p:txBody>
-      </p:sp>
-      <p:sp>
-        <p:nvSpPr>
-          <p:cNvPr id="16" name="TextBox 15"/>
-          <p:cNvSpPr txBox="1"/>
-          <p:nvPr/>
-        </p:nvSpPr>
-        <p:spPr>
-          <a:xfrm>
-            <a:off x="4419600" y="4000500"/>
-            <a:ext cx="3302000" cy="762000"/>
-          </a:xfrm>
-          <a:prstGeom prst="rect">
-            <a:avLst/>
-          </a:prstGeom>
-          <a:noFill/>
-        </p:spPr>
-        <p:txBody>
-          <a:bodyPr wrap="square" lIns="0" rIns="0" tIns="0" bIns="0" anchor="t">
-            <a:spAutoFit/>
-          </a:bodyPr>
-          <a:lstStyle/>
-          <a:p>
-            <a:pPr algn="l">
-              <a:lnSpc>
-                <a:spcPct val="125000"/>
-              </a:lnSpc>
-              <a:spcAft>
-                <a:spcPts val="0"/>
-              </a:spcAft>
-            </a:pPr>
-            <a:r>
-              <a:rPr sz="1609" b="0" i="0">
-                <a:solidFill>
-                  <a:srgbClr val="3A4F63"/>
-                </a:solidFill>
-                <a:latin typeface="DM Sans"/>
-              </a:rPr>
-              <a:t>elke zes maanden en op het einde · 60 tot 90 minuten</a:t>
-            </a:r>
-          </a:p>
-        </p:txBody>
-      </p:sp>
-      <p:cxnSp>
-        <p:nvCxnSpPr>
-          <p:cNvPr id="17" name="Connector 16"/>
-          <p:cNvCxnSpPr/>
-          <p:nvPr/>
-        </p:nvCxnSpPr>
-        <p:spPr>
-          <a:xfrm>
-            <a:off x="8026400" y="2095500"/>
-            <a:ext cx="3302000" cy="0"/>
-          </a:xfrm>
-          <a:prstGeom prst="line">
-            <a:avLst/>
-          </a:prstGeom>
-          <a:ln w="19050">
-            <a:solidFill>
-              <a:srgbClr val="0B6E8F"/>
-            </a:solidFill>
-          </a:ln>
-        </p:spPr>
-        <p:style>
-          <a:lnRef idx="2">
-            <a:schemeClr val="accent1"/>
-          </a:lnRef>
-          <a:fillRef idx="0">
-            <a:schemeClr val="accent1"/>
-          </a:fillRef>
-          <a:effectRef idx="1">
-            <a:schemeClr val="accent1"/>
-          </a:effectRef>
-          <a:fontRef idx="minor">
-            <a:schemeClr val="tx1"/>
-          </a:fontRef>
-        </p:style>
-      </p:cxnSp>
-      <p:sp>
-        <p:nvSpPr>
-          <p:cNvPr id="18" name="TextBox 17"/>
-          <p:cNvSpPr txBox="1"/>
-          <p:nvPr/>
-        </p:nvSpPr>
-        <p:spPr>
-          <a:xfrm>
-            <a:off x="8026400" y="2260600"/>
-            <a:ext cx="3302000" cy="381000"/>
-          </a:xfrm>
-          <a:prstGeom prst="rect">
-            <a:avLst/>
-          </a:prstGeom>
-          <a:noFill/>
-        </p:spPr>
-        <p:txBody>
-          <a:bodyPr wrap="square" lIns="0" rIns="0" tIns="0" bIns="0" anchor="t">
-            <a:spAutoFit/>
-          </a:bodyPr>
-          <a:lstStyle/>
-          <a:p>
-            <a:pPr algn="l">
-              <a:lnSpc>
-                <a:spcPct val="125000"/>
-              </a:lnSpc>
-              <a:spcAft>
-                <a:spcPts val="0"/>
-              </a:spcAft>
-            </a:pPr>
-            <a:r>
-              <a:rPr sz="2529" b="0" i="0">
-                <a:solidFill>
-                  <a:srgbClr val="0A2540"/>
-                </a:solidFill>
-                <a:latin typeface="DM Serif Display"/>
-              </a:rPr>
-              <a:t>Management</a:t>
-            </a:r>
-          </a:p>
-        </p:txBody>
-      </p:sp>
-      <p:sp>
-        <p:nvSpPr>
-          <p:cNvPr id="19" name="TextBox 18"/>
-          <p:cNvSpPr txBox="1"/>
-          <p:nvPr/>
-        </p:nvSpPr>
-        <p:spPr>
-          <a:xfrm>
-            <a:off x="8026400" y="2667000"/>
-            <a:ext cx="3302000" cy="228600"/>
-          </a:xfrm>
-          <a:prstGeom prst="rect">
-            <a:avLst/>
-          </a:prstGeom>
-          <a:noFill/>
-        </p:spPr>
-        <p:txBody>
-          <a:bodyPr wrap="square" lIns="0" rIns="0" tIns="0" bIns="0" anchor="t">
-            <a:spAutoFit/>
-          </a:bodyPr>
-          <a:lstStyle/>
-          <a:p>
-            <a:pPr algn="l">
-              <a:lnSpc>
-                <a:spcPct val="125000"/>
-              </a:lnSpc>
-              <a:spcAft>
-                <a:spcPts val="0"/>
-              </a:spcAft>
-            </a:pPr>
-            <a:r>
-              <a:rPr sz="1380" b="0" i="0">
-                <a:solidFill>
-                  <a:srgbClr val="5A6E80"/>
-                </a:solidFill>
-                <a:latin typeface="DM Sans"/>
-              </a:rPr>
-              <a:t>eCRF 43</a:t>
-            </a:r>
-          </a:p>
-        </p:txBody>
-      </p:sp>
-      <p:sp>
-        <p:nvSpPr>
-          <p:cNvPr id="20" name="TextBox 19"/>
-          <p:cNvSpPr txBox="1"/>
-          <p:nvPr/>
-        </p:nvSpPr>
-        <p:spPr>
-          <a:xfrm>
-            <a:off x="8026400" y="3048000"/>
-            <a:ext cx="3302000" cy="762000"/>
-          </a:xfrm>
-          <a:prstGeom prst="rect">
-            <a:avLst/>
-          </a:prstGeom>
-          <a:noFill/>
-        </p:spPr>
-        <p:txBody>
-          <a:bodyPr wrap="square" lIns="0" rIns="0" tIns="0" bIns="0" anchor="t">
-            <a:spAutoFit/>
-          </a:bodyPr>
-          <a:lstStyle/>
-          <a:p>
-            <a:pPr algn="l">
-              <a:lnSpc>
-                <a:spcPct val="100000"/>
-              </a:lnSpc>
-              <a:spcAft>
-                <a:spcPts val="0"/>
-              </a:spcAft>
-            </a:pPr>
-            <a:r>
-              <a:rPr sz="2990" b="0" i="0">
-                <a:solidFill>
-                  <a:srgbClr val="0B6E8F"/>
-                </a:solidFill>
-                <a:latin typeface="DM Serif Display"/>
-              </a:rPr>
-              <a:t>PI + coördinator</a:t>
-            </a:r>
-          </a:p>
-        </p:txBody>
-      </p:sp>
-      <p:sp>
-        <p:nvSpPr>
-          <p:cNvPr id="21" name="TextBox 20"/>
-          <p:cNvSpPr txBox="1"/>
-          <p:nvPr/>
-        </p:nvSpPr>
-        <p:spPr>
-          <a:xfrm>
-            <a:off x="8026400" y="4000500"/>
-            <a:ext cx="3302000" cy="762000"/>
-          </a:xfrm>
-          <a:prstGeom prst="rect">
-            <a:avLst/>
-          </a:prstGeom>
-          <a:noFill/>
-        </p:spPr>
-        <p:txBody>
-          <a:bodyPr wrap="square" lIns="0" rIns="0" tIns="0" bIns="0" anchor="t">
-            <a:spAutoFit/>
-          </a:bodyPr>
-          <a:lstStyle/>
-          <a:p>
-            <a:pPr algn="l">
-              <a:lnSpc>
-                <a:spcPct val="125000"/>
-              </a:lnSpc>
-              <a:spcAft>
-                <a:spcPts val="0"/>
-              </a:spcAft>
-            </a:pPr>
-            <a:r>
-              <a:rPr sz="1609" b="0" i="0">
-                <a:solidFill>
-                  <a:srgbClr val="3A4F63"/>
-                </a:solidFill>
-                <a:latin typeface="DM Sans"/>
-              </a:rPr>
-              <a:t>op het einde van de studie · 60 tot 90 minuten</a:t>
-            </a:r>
-          </a:p>
-        </p:txBody>
-      </p:sp>
-      <p:cxnSp>
-        <p:nvCxnSpPr>
-          <p:cNvPr id="22" name="Connector 21"/>
-          <p:cNvCxnSpPr/>
-          <p:nvPr/>
-        </p:nvCxnSpPr>
-        <p:spPr>
-          <a:xfrm>
-            <a:off x="812800" y="5080000"/>
-            <a:ext cx="10566400" cy="0"/>
-          </a:xfrm>
-          <a:prstGeom prst="line">
-            <a:avLst/>
-          </a:prstGeom>
-          <a:ln w="6350">
-            <a:solidFill>
-              <a:srgbClr val="D3DFE8"/>
-            </a:solidFill>
-          </a:ln>
-        </p:spPr>
-        <p:style>
-          <a:lnRef idx="2">
-            <a:schemeClr val="accent1"/>
-          </a:lnRef>
-          <a:fillRef idx="0">
-            <a:schemeClr val="accent1"/>
-          </a:fillRef>
-          <a:effectRef idx="1">
-            <a:schemeClr val="accent1"/>
-          </a:effectRef>
-          <a:fontRef idx="minor">
-            <a:schemeClr val="tx1"/>
-          </a:fontRef>
-        </p:style>
-      </p:cxnSp>
+              <a:t>Gescoord uit de video-opnames, per visite de onderdelen van die visite (V1 tot V8).</a:t>
+            </a:r>
+          </a:p>
+        </p:txBody>
+      </p:sp>
     </p:spTree>
   </p:cSld>
   <p:clrMapOvr>
@@ -17185,7 +17076,7 @@
                 </a:solidFill>
                 <a:latin typeface="DM Serif Display"/>
               </a:rPr>
-              <a:t>Fideliteit: elk scriptonderdeel krijgt een score</a:t>
+              <a:t>Wat uw team doet voor de procesevaluatie</a:t>
             </a:r>
           </a:p>
         </p:txBody>
@@ -17293,273 +17184,21 @@
                 </a:solidFill>
                 <a:latin typeface="DM Sans"/>
               </a:rPr>
-              <a:t>Bron: eCRF 44 (fidelity checklist) · eCRF 17 (SEBIA-script)</a:t>
-            </a:r>
-          </a:p>
-        </p:txBody>
-      </p:sp>
-      <p:sp>
-        <p:nvSpPr>
-          <p:cNvPr id="7" name="TextBox 6"/>
-          <p:cNvSpPr txBox="1"/>
-          <p:nvPr/>
-        </p:nvSpPr>
-        <p:spPr>
-          <a:xfrm>
-            <a:off x="812800" y="2095500"/>
-            <a:ext cx="1905000" cy="1270000"/>
-          </a:xfrm>
-          <a:prstGeom prst="rect">
-            <a:avLst/>
-          </a:prstGeom>
-          <a:noFill/>
-        </p:spPr>
-        <p:txBody>
-          <a:bodyPr wrap="square" lIns="0" rIns="0" tIns="0" bIns="0" anchor="t">
-            <a:spAutoFit/>
-          </a:bodyPr>
-          <a:lstStyle/>
-          <a:p>
-            <a:pPr algn="l">
-              <a:lnSpc>
-                <a:spcPct val="90000"/>
-              </a:lnSpc>
-              <a:spcAft>
-                <a:spcPts val="0"/>
-              </a:spcAft>
-            </a:pPr>
-            <a:r>
-              <a:rPr sz="9000" b="0" i="0">
-                <a:solidFill>
-                  <a:srgbClr val="0B6E8F"/>
-                </a:solidFill>
-                <a:latin typeface="DM Serif Display"/>
-              </a:rPr>
-              <a:t>0</a:t>
-            </a:r>
-          </a:p>
-        </p:txBody>
-      </p:sp>
-      <p:sp>
-        <p:nvSpPr>
-          <p:cNvPr id="8" name="TextBox 7"/>
-          <p:cNvSpPr txBox="1"/>
-          <p:nvPr/>
-        </p:nvSpPr>
-        <p:spPr>
-          <a:xfrm>
-            <a:off x="812800" y="3429000"/>
-            <a:ext cx="2095500" cy="317500"/>
-          </a:xfrm>
-          <a:prstGeom prst="rect">
-            <a:avLst/>
-          </a:prstGeom>
-          <a:noFill/>
-        </p:spPr>
-        <p:txBody>
-          <a:bodyPr wrap="square" lIns="0" rIns="0" tIns="0" bIns="0" anchor="t">
-            <a:spAutoFit/>
-          </a:bodyPr>
-          <a:lstStyle/>
-          <a:p>
-            <a:pPr algn="l">
-              <a:lnSpc>
-                <a:spcPct val="125000"/>
-              </a:lnSpc>
-              <a:spcAft>
-                <a:spcPts val="0"/>
-              </a:spcAft>
-            </a:pPr>
-            <a:r>
-              <a:rPr sz="1839" b="0" i="0">
-                <a:solidFill>
-                  <a:srgbClr val="0A2540"/>
-                </a:solidFill>
-                <a:latin typeface="DM Sans"/>
-              </a:rPr>
-              <a:t>niet uitgevoerd</a:t>
-            </a:r>
-          </a:p>
-        </p:txBody>
-      </p:sp>
-      <p:sp>
-        <p:nvSpPr>
-          <p:cNvPr id="9" name="TextBox 8"/>
-          <p:cNvSpPr txBox="1"/>
-          <p:nvPr/>
-        </p:nvSpPr>
-        <p:spPr>
-          <a:xfrm>
-            <a:off x="3225800" y="2095500"/>
-            <a:ext cx="1905000" cy="1270000"/>
-          </a:xfrm>
-          <a:prstGeom prst="rect">
-            <a:avLst/>
-          </a:prstGeom>
-          <a:noFill/>
-        </p:spPr>
-        <p:txBody>
-          <a:bodyPr wrap="square" lIns="0" rIns="0" tIns="0" bIns="0" anchor="t">
-            <a:spAutoFit/>
-          </a:bodyPr>
-          <a:lstStyle/>
-          <a:p>
-            <a:pPr algn="l">
-              <a:lnSpc>
-                <a:spcPct val="90000"/>
-              </a:lnSpc>
-              <a:spcAft>
-                <a:spcPts val="0"/>
-              </a:spcAft>
-            </a:pPr>
-            <a:r>
-              <a:rPr sz="9000" b="0" i="0">
-                <a:solidFill>
-                  <a:srgbClr val="0B6E8F"/>
-                </a:solidFill>
-                <a:latin typeface="DM Serif Display"/>
-              </a:rPr>
-              <a:t>1</a:t>
-            </a:r>
-          </a:p>
-        </p:txBody>
-      </p:sp>
-      <p:sp>
-        <p:nvSpPr>
-          <p:cNvPr id="10" name="TextBox 9"/>
-          <p:cNvSpPr txBox="1"/>
-          <p:nvPr/>
-        </p:nvSpPr>
-        <p:spPr>
-          <a:xfrm>
-            <a:off x="3225800" y="3429000"/>
-            <a:ext cx="2095500" cy="317500"/>
-          </a:xfrm>
-          <a:prstGeom prst="rect">
-            <a:avLst/>
-          </a:prstGeom>
-          <a:noFill/>
-        </p:spPr>
-        <p:txBody>
-          <a:bodyPr wrap="square" lIns="0" rIns="0" tIns="0" bIns="0" anchor="t">
-            <a:spAutoFit/>
-          </a:bodyPr>
-          <a:lstStyle/>
-          <a:p>
-            <a:pPr algn="l">
-              <a:lnSpc>
-                <a:spcPct val="125000"/>
-              </a:lnSpc>
-              <a:spcAft>
-                <a:spcPts val="0"/>
-              </a:spcAft>
-            </a:pPr>
-            <a:r>
-              <a:rPr sz="1839" b="0" i="0">
-                <a:solidFill>
-                  <a:srgbClr val="0A2540"/>
-                </a:solidFill>
-                <a:latin typeface="DM Sans"/>
-              </a:rPr>
-              <a:t>gedeeltelijk</a:t>
-            </a:r>
-          </a:p>
-        </p:txBody>
-      </p:sp>
-      <p:sp>
-        <p:nvSpPr>
-          <p:cNvPr id="11" name="TextBox 10"/>
-          <p:cNvSpPr txBox="1"/>
-          <p:nvPr/>
-        </p:nvSpPr>
-        <p:spPr>
-          <a:xfrm>
-            <a:off x="5638800" y="2095500"/>
-            <a:ext cx="1905000" cy="1270000"/>
-          </a:xfrm>
-          <a:prstGeom prst="rect">
-            <a:avLst/>
-          </a:prstGeom>
-          <a:noFill/>
-        </p:spPr>
-        <p:txBody>
-          <a:bodyPr wrap="square" lIns="0" rIns="0" tIns="0" bIns="0" anchor="t">
-            <a:spAutoFit/>
-          </a:bodyPr>
-          <a:lstStyle/>
-          <a:p>
-            <a:pPr algn="l">
-              <a:lnSpc>
-                <a:spcPct val="90000"/>
-              </a:lnSpc>
-              <a:spcAft>
-                <a:spcPts val="0"/>
-              </a:spcAft>
-            </a:pPr>
-            <a:r>
-              <a:rPr sz="9000" b="0" i="0">
-                <a:solidFill>
-                  <a:srgbClr val="0B6E8F"/>
-                </a:solidFill>
-                <a:latin typeface="DM Serif Display"/>
-              </a:rPr>
-              <a:t>2</a:t>
-            </a:r>
-          </a:p>
-        </p:txBody>
-      </p:sp>
-      <p:sp>
-        <p:nvSpPr>
-          <p:cNvPr id="12" name="TextBox 11"/>
-          <p:cNvSpPr txBox="1"/>
-          <p:nvPr/>
-        </p:nvSpPr>
-        <p:spPr>
-          <a:xfrm>
-            <a:off x="5638800" y="3429000"/>
-            <a:ext cx="2095500" cy="317500"/>
-          </a:xfrm>
-          <a:prstGeom prst="rect">
-            <a:avLst/>
-          </a:prstGeom>
-          <a:noFill/>
-        </p:spPr>
-        <p:txBody>
-          <a:bodyPr wrap="square" lIns="0" rIns="0" tIns="0" bIns="0" anchor="t">
-            <a:spAutoFit/>
-          </a:bodyPr>
-          <a:lstStyle/>
-          <a:p>
-            <a:pPr algn="l">
-              <a:lnSpc>
-                <a:spcPct val="125000"/>
-              </a:lnSpc>
-              <a:spcAft>
-                <a:spcPts val="0"/>
-              </a:spcAft>
-            </a:pPr>
-            <a:r>
-              <a:rPr sz="1839" b="0" i="0">
-                <a:solidFill>
-                  <a:srgbClr val="0A2540"/>
-                </a:solidFill>
-                <a:latin typeface="DM Sans"/>
-              </a:rPr>
-              <a:t>volledig</a:t>
+              <a:t>Bron: eCRF 39 · eCRF 40 en 44 · toestemmingsformulier patiënt (eCRF 02)</a:t>
             </a:r>
           </a:p>
         </p:txBody>
       </p:sp>
       <p:cxnSp>
         <p:nvCxnSpPr>
-          <p:cNvPr id="13" name="Connector 12"/>
+          <p:cNvPr id="7" name="Connector 6"/>
           <p:cNvCxnSpPr/>
           <p:nvPr/>
         </p:nvCxnSpPr>
         <p:spPr>
           <a:xfrm>
-            <a:off x="8191500" y="2159000"/>
-            <a:ext cx="0" cy="1905000"/>
+            <a:off x="812800" y="2095500"/>
+            <a:ext cx="10566400" cy="0"/>
           </a:xfrm>
           <a:prstGeom prst="line">
             <a:avLst/>
@@ -17587,14 +17226,14 @@
       </p:cxnSp>
       <p:sp>
         <p:nvSpPr>
-          <p:cNvPr id="14" name="TextBox 13"/>
-          <p:cNvSpPr txBox="1"/>
-          <p:nvPr/>
-        </p:nvSpPr>
-        <p:spPr>
-          <a:xfrm>
-            <a:off x="8509000" y="2159000"/>
-            <a:ext cx="2870200" cy="2032000"/>
+          <p:cNvPr id="8" name="TextBox 7"/>
+          <p:cNvSpPr txBox="1"/>
+          <p:nvPr/>
+        </p:nvSpPr>
+        <p:spPr>
+          <a:xfrm>
+            <a:off x="812800" y="2260600"/>
+            <a:ext cx="2984500" cy="571500"/>
           </a:xfrm>
           <a:prstGeom prst="rect">
             <a:avLst/>
@@ -17612,87 +17251,162 @@
                 <a:spcPct val="125000"/>
               </a:lnSpc>
               <a:spcAft>
-                <a:spcPts val="400"/>
-              </a:spcAft>
-            </a:pPr>
-            <a:r>
-              <a:rPr sz="1609" b="0" i="0">
+                <a:spcPts val="0"/>
+              </a:spcAft>
+            </a:pPr>
+            <a:r>
+              <a:rPr sz="1954" b="0" i="0">
+                <a:solidFill>
+                  <a:srgbClr val="A34A00"/>
+                </a:solidFill>
+                <a:latin typeface="DM Serif Display"/>
+              </a:rPr>
+              <a:t>Na elke sessie</a:t>
+            </a:r>
+          </a:p>
+        </p:txBody>
+      </p:sp>
+      <p:sp>
+        <p:nvSpPr>
+          <p:cNvPr id="9" name="TextBox 8"/>
+          <p:cNvSpPr txBox="1"/>
+          <p:nvPr/>
+        </p:nvSpPr>
+        <p:spPr>
+          <a:xfrm>
+            <a:off x="4064000" y="2273300"/>
+            <a:ext cx="5715000" cy="698500"/>
+          </a:xfrm>
+          <a:prstGeom prst="rect">
+            <a:avLst/>
+          </a:prstGeom>
+          <a:noFill/>
+        </p:spPr>
+        <p:txBody>
+          <a:bodyPr wrap="square" lIns="0" rIns="0" tIns="0" bIns="0" anchor="t">
+            <a:spAutoFit/>
+          </a:bodyPr>
+          <a:lstStyle/>
+          <a:p>
+            <a:pPr algn="l">
+              <a:lnSpc>
+                <a:spcPct val="125000"/>
+              </a:lnSpc>
+              <a:spcAft>
+                <a:spcPts val="0"/>
+              </a:spcAft>
+            </a:pPr>
+            <a:r>
+              <a:rPr sz="1725" b="0" i="0">
                 <a:solidFill>
                   <a:srgbClr val="3A4F63"/>
                 </a:solidFill>
                 <a:latin typeface="DM Sans"/>
               </a:rPr>
-              <a:t>Ook gescoord:</a:t>
-            </a:r>
-          </a:p>
-          <a:p>
-            <a:pPr algn="l">
+              <a:t>Het dagboek invullen (eCRF 40)</a:t>
+            </a:r>
+          </a:p>
+        </p:txBody>
+      </p:sp>
+      <p:sp>
+        <p:nvSpPr>
+          <p:cNvPr id="10" name="Rounded Rectangle 9"/>
+          <p:cNvSpPr/>
+          <p:nvPr/>
+        </p:nvSpPr>
+        <p:spPr>
+          <a:xfrm>
+            <a:off x="9677400" y="2247900"/>
+            <a:ext cx="1701800" cy="355600"/>
+          </a:xfrm>
+          <a:prstGeom prst="roundRect">
+            <a:avLst>
+              <a:gd name="adj" fmla="val 50000"/>
+            </a:avLst>
+          </a:prstGeom>
+          <a:solidFill>
+            <a:srgbClr val="FFFFFF"/>
+          </a:solidFill>
+          <a:ln w="15875">
+            <a:solidFill>
+              <a:srgbClr val="0B6E8F"/>
+            </a:solidFill>
+          </a:ln>
+          <a:effectLst/>
+        </p:spPr>
+        <p:style>
+          <a:lnRef idx="1">
+            <a:schemeClr val="accent1"/>
+          </a:lnRef>
+          <a:fillRef idx="3">
+            <a:schemeClr val="accent1"/>
+          </a:fillRef>
+          <a:effectRef idx="2">
+            <a:schemeClr val="accent1"/>
+          </a:effectRef>
+          <a:fontRef idx="minor">
+            <a:schemeClr val="lt1"/>
+          </a:fontRef>
+        </p:style>
+        <p:txBody>
+          <a:bodyPr rtlCol="0" anchor="ctr"/>
+          <a:lstStyle/>
+          <a:p>
+            <a:pPr algn="ctr"/>
+          </a:p>
+        </p:txBody>
+      </p:sp>
+      <p:sp>
+        <p:nvSpPr>
+          <p:cNvPr id="11" name="TextBox 10"/>
+          <p:cNvSpPr txBox="1"/>
+          <p:nvPr/>
+        </p:nvSpPr>
+        <p:spPr>
+          <a:xfrm>
+            <a:off x="9677400" y="2305050"/>
+            <a:ext cx="1701800" cy="254000"/>
+          </a:xfrm>
+          <a:prstGeom prst="rect">
+            <a:avLst/>
+          </a:prstGeom>
+          <a:noFill/>
+        </p:spPr>
+        <p:txBody>
+          <a:bodyPr wrap="square" lIns="0" rIns="0" tIns="0" bIns="0" anchor="t">
+            <a:spAutoFit/>
+          </a:bodyPr>
+          <a:lstStyle/>
+          <a:p>
+            <a:pPr algn="ctr">
               <a:lnSpc>
                 <a:spcPct val="125000"/>
               </a:lnSpc>
               <a:spcAft>
-                <a:spcPts val="400"/>
-              </a:spcAft>
-            </a:pPr>
-            <a:r>
-              <a:rPr sz="1609" b="0" i="0">
-                <a:solidFill>
-                  <a:srgbClr val="3A4F63"/>
+                <a:spcPts val="0"/>
+              </a:spcAft>
+            </a:pPr>
+            <a:r>
+              <a:rPr sz="1500" b="1" i="0">
+                <a:solidFill>
+                  <a:srgbClr val="0B6E8F"/>
                 </a:solidFill>
                 <a:latin typeface="DM Sans"/>
               </a:rPr>
-              <a:t>didactiek</a:t>
-            </a:r>
-          </a:p>
-          <a:p>
-            <a:pPr algn="l">
-              <a:lnSpc>
-                <a:spcPct val="125000"/>
-              </a:lnSpc>
-              <a:spcAft>
-                <a:spcPts val="400"/>
-              </a:spcAft>
-            </a:pPr>
-            <a:r>
-              <a:rPr sz="1609" b="0" i="0">
-                <a:solidFill>
-                  <a:srgbClr val="3A4F63"/>
-                </a:solidFill>
-                <a:latin typeface="DM Sans"/>
-              </a:rPr>
-              <a:t>motiverende gespreksvoering</a:t>
-            </a:r>
-          </a:p>
-          <a:p>
-            <a:pPr algn="l">
-              <a:lnSpc>
-                <a:spcPct val="125000"/>
-              </a:lnSpc>
-              <a:spcAft>
-                <a:spcPts val="400"/>
-              </a:spcAft>
-            </a:pPr>
-            <a:r>
-              <a:rPr sz="1609" b="0" i="0">
-                <a:solidFill>
-                  <a:srgbClr val="3A4F63"/>
-                </a:solidFill>
-                <a:latin typeface="DM Sans"/>
-              </a:rPr>
-              <a:t>wat de deelnemer kan navertellen</a:t>
+              <a:t>Optimal Care</a:t>
             </a:r>
           </a:p>
         </p:txBody>
       </p:sp>
       <p:cxnSp>
         <p:nvCxnSpPr>
-          <p:cNvPr id="15" name="Connector 14"/>
+          <p:cNvPr id="12" name="Connector 11"/>
           <p:cNvCxnSpPr/>
           <p:nvPr/>
         </p:nvCxnSpPr>
         <p:spPr>
           <a:xfrm>
-            <a:off x="812800" y="4445000"/>
+            <a:off x="812800" y="3048000"/>
             <a:ext cx="10566400" cy="0"/>
           </a:xfrm>
           <a:prstGeom prst="line">
@@ -17721,14 +17435,146 @@
       </p:cxnSp>
       <p:sp>
         <p:nvSpPr>
+          <p:cNvPr id="13" name="TextBox 12"/>
+          <p:cNvSpPr txBox="1"/>
+          <p:nvPr/>
+        </p:nvSpPr>
+        <p:spPr>
+          <a:xfrm>
+            <a:off x="812800" y="3213100"/>
+            <a:ext cx="2984500" cy="571500"/>
+          </a:xfrm>
+          <a:prstGeom prst="rect">
+            <a:avLst/>
+          </a:prstGeom>
+          <a:noFill/>
+        </p:spPr>
+        <p:txBody>
+          <a:bodyPr wrap="square" lIns="0" rIns="0" tIns="0" bIns="0" anchor="t">
+            <a:spAutoFit/>
+          </a:bodyPr>
+          <a:lstStyle/>
+          <a:p>
+            <a:pPr algn="l">
+              <a:lnSpc>
+                <a:spcPct val="125000"/>
+              </a:lnSpc>
+              <a:spcAft>
+                <a:spcPts val="0"/>
+              </a:spcAft>
+            </a:pPr>
+            <a:r>
+              <a:rPr sz="1954" b="0" i="0">
+                <a:solidFill>
+                  <a:srgbClr val="A34A00"/>
+                </a:solidFill>
+                <a:latin typeface="DM Serif Display"/>
+              </a:rPr>
+              <a:t>Twee sessies per patiënt</a:t>
+            </a:r>
+          </a:p>
+        </p:txBody>
+      </p:sp>
+      <p:sp>
+        <p:nvSpPr>
+          <p:cNvPr id="14" name="TextBox 13"/>
+          <p:cNvSpPr txBox="1"/>
+          <p:nvPr/>
+        </p:nvSpPr>
+        <p:spPr>
+          <a:xfrm>
+            <a:off x="4064000" y="3225800"/>
+            <a:ext cx="5715000" cy="698500"/>
+          </a:xfrm>
+          <a:prstGeom prst="rect">
+            <a:avLst/>
+          </a:prstGeom>
+          <a:noFill/>
+        </p:spPr>
+        <p:txBody>
+          <a:bodyPr wrap="square" lIns="0" rIns="0" tIns="0" bIns="0" anchor="t">
+            <a:spAutoFit/>
+          </a:bodyPr>
+          <a:lstStyle/>
+          <a:p>
+            <a:pPr algn="l">
+              <a:lnSpc>
+                <a:spcPct val="125000"/>
+              </a:lnSpc>
+              <a:spcAft>
+                <a:spcPts val="0"/>
+              </a:spcAft>
+            </a:pPr>
+            <a:r>
+              <a:rPr sz="1725" b="0" i="0">
+                <a:solidFill>
+                  <a:srgbClr val="3A4F63"/>
+                </a:solidFill>
+                <a:latin typeface="DM Sans"/>
+              </a:rPr>
+              <a:t>Op video, willekeurig gekozen, en gescoord met de fidelity-checklist (eCRF 44)</a:t>
+            </a:r>
+          </a:p>
+        </p:txBody>
+      </p:sp>
+      <p:sp>
+        <p:nvSpPr>
+          <p:cNvPr id="15" name="Rounded Rectangle 14"/>
+          <p:cNvSpPr/>
+          <p:nvPr/>
+        </p:nvSpPr>
+        <p:spPr>
+          <a:xfrm>
+            <a:off x="9677400" y="3200400"/>
+            <a:ext cx="1701800" cy="355600"/>
+          </a:xfrm>
+          <a:prstGeom prst="roundRect">
+            <a:avLst>
+              <a:gd name="adj" fmla="val 50000"/>
+            </a:avLst>
+          </a:prstGeom>
+          <a:solidFill>
+            <a:srgbClr val="FFFFFF"/>
+          </a:solidFill>
+          <a:ln w="15875">
+            <a:solidFill>
+              <a:srgbClr val="0B6E8F"/>
+            </a:solidFill>
+          </a:ln>
+          <a:effectLst/>
+        </p:spPr>
+        <p:style>
+          <a:lnRef idx="1">
+            <a:schemeClr val="accent1"/>
+          </a:lnRef>
+          <a:fillRef idx="3">
+            <a:schemeClr val="accent1"/>
+          </a:fillRef>
+          <a:effectRef idx="2">
+            <a:schemeClr val="accent1"/>
+          </a:effectRef>
+          <a:fontRef idx="minor">
+            <a:schemeClr val="lt1"/>
+          </a:fontRef>
+        </p:style>
+        <p:txBody>
+          <a:bodyPr rtlCol="0" anchor="ctr"/>
+          <a:lstStyle/>
+          <a:p>
+            <a:pPr algn="ctr"/>
+          </a:p>
+        </p:txBody>
+      </p:sp>
+      <p:sp>
+        <p:nvSpPr>
           <p:cNvPr id="16" name="TextBox 15"/>
           <p:cNvSpPr txBox="1"/>
           <p:nvPr/>
         </p:nvSpPr>
         <p:spPr>
           <a:xfrm>
-            <a:off x="812800" y="4597400"/>
-            <a:ext cx="10566400" cy="317500"/>
+            <a:off x="9677400" y="3257550"/>
+            <a:ext cx="1701800" cy="254000"/>
           </a:xfrm>
           <a:prstGeom prst="rect">
             <a:avLst/>
@@ -17741,6 +17587,83 @@
           </a:bodyPr>
           <a:lstStyle/>
           <a:p>
+            <a:pPr algn="ctr">
+              <a:lnSpc>
+                <a:spcPct val="125000"/>
+              </a:lnSpc>
+              <a:spcAft>
+                <a:spcPts val="0"/>
+              </a:spcAft>
+            </a:pPr>
+            <a:r>
+              <a:rPr sz="1500" b="1" i="0">
+                <a:solidFill>
+                  <a:srgbClr val="0B6E8F"/>
+                </a:solidFill>
+                <a:latin typeface="DM Sans"/>
+              </a:rPr>
+              <a:t>Optimal Care</a:t>
+            </a:r>
+          </a:p>
+        </p:txBody>
+      </p:sp>
+      <p:cxnSp>
+        <p:nvCxnSpPr>
+          <p:cNvPr id="17" name="Connector 16"/>
+          <p:cNvCxnSpPr/>
+          <p:nvPr/>
+        </p:nvCxnSpPr>
+        <p:spPr>
+          <a:xfrm>
+            <a:off x="812800" y="4000500"/>
+            <a:ext cx="10566400" cy="0"/>
+          </a:xfrm>
+          <a:prstGeom prst="line">
+            <a:avLst/>
+          </a:prstGeom>
+          <a:ln w="6350">
+            <a:solidFill>
+              <a:srgbClr val="D3DFE8"/>
+            </a:solidFill>
+          </a:ln>
+        </p:spPr>
+        <p:style>
+          <a:lnRef idx="2">
+            <a:schemeClr val="accent1"/>
+          </a:lnRef>
+          <a:fillRef idx="0">
+            <a:schemeClr val="accent1"/>
+          </a:fillRef>
+          <a:effectRef idx="1">
+            <a:schemeClr val="accent1"/>
+          </a:effectRef>
+          <a:fontRef idx="minor">
+            <a:schemeClr val="tx1"/>
+          </a:fontRef>
+        </p:style>
+      </p:cxnSp>
+      <p:sp>
+        <p:nvSpPr>
+          <p:cNvPr id="18" name="TextBox 17"/>
+          <p:cNvSpPr txBox="1"/>
+          <p:nvPr/>
+        </p:nvSpPr>
+        <p:spPr>
+          <a:xfrm>
+            <a:off x="812800" y="4165600"/>
+            <a:ext cx="2984500" cy="571500"/>
+          </a:xfrm>
+          <a:prstGeom prst="rect">
+            <a:avLst/>
+          </a:prstGeom>
+          <a:noFill/>
+        </p:spPr>
+        <p:txBody>
+          <a:bodyPr wrap="square" lIns="0" rIns="0" tIns="0" bIns="0" anchor="t">
+            <a:spAutoFit/>
+          </a:bodyPr>
+          <a:lstStyle/>
+          <a:p>
             <a:pPr algn="l">
               <a:lnSpc>
                 <a:spcPct val="125000"/>
@@ -17750,17 +17673,94 @@
               </a:spcAft>
             </a:pPr>
             <a:r>
+              <a:rPr sz="1954" b="0" i="0">
+                <a:solidFill>
+                  <a:srgbClr val="A34A00"/>
+                </a:solidFill>
+                <a:latin typeface="DM Serif Display"/>
+              </a:rPr>
+              <a:t>Elke zes maanden</a:t>
+            </a:r>
+          </a:p>
+        </p:txBody>
+      </p:sp>
+      <p:sp>
+        <p:nvSpPr>
+          <p:cNvPr id="19" name="TextBox 18"/>
+          <p:cNvSpPr txBox="1"/>
+          <p:nvPr/>
+        </p:nvSpPr>
+        <p:spPr>
+          <a:xfrm>
+            <a:off x="4064000" y="4178300"/>
+            <a:ext cx="7302500" cy="698500"/>
+          </a:xfrm>
+          <a:prstGeom prst="rect">
+            <a:avLst/>
+          </a:prstGeom>
+          <a:noFill/>
+        </p:spPr>
+        <p:txBody>
+          <a:bodyPr wrap="square" lIns="0" rIns="0" tIns="0" bIns="0" anchor="t">
+            <a:spAutoFit/>
+          </a:bodyPr>
+          <a:lstStyle/>
+          <a:p>
+            <a:pPr algn="l">
+              <a:lnSpc>
+                <a:spcPct val="125000"/>
+              </a:lnSpc>
+              <a:spcAft>
+                <a:spcPts val="0"/>
+              </a:spcAft>
+            </a:pPr>
+            <a:r>
               <a:rPr sz="1725" b="0" i="0">
                 <a:solidFill>
                   <a:srgbClr val="3A4F63"/>
                 </a:solidFill>
                 <a:latin typeface="DM Sans"/>
               </a:rPr>
-              <a:t>Per visite de onderdelen van die visite, van V1 tot V8.</a:t>
-            </a:r>
-          </a:p>
-        </p:txBody>
-      </p:sp>
+              <a:t>Community of practice: podologen en pedorthisten delen ervaringen en aanpassingen</a:t>
+            </a:r>
+          </a:p>
+        </p:txBody>
+      </p:sp>
+      <p:cxnSp>
+        <p:nvCxnSpPr>
+          <p:cNvPr id="20" name="Connector 19"/>
+          <p:cNvCxnSpPr/>
+          <p:nvPr/>
+        </p:nvCxnSpPr>
+        <p:spPr>
+          <a:xfrm>
+            <a:off x="812800" y="4953000"/>
+            <a:ext cx="10566400" cy="0"/>
+          </a:xfrm>
+          <a:prstGeom prst="line">
+            <a:avLst/>
+          </a:prstGeom>
+          <a:ln w="6350">
+            <a:solidFill>
+              <a:srgbClr val="D3DFE8"/>
+            </a:solidFill>
+          </a:ln>
+        </p:spPr>
+        <p:style>
+          <a:lnRef idx="2">
+            <a:schemeClr val="accent1"/>
+          </a:lnRef>
+          <a:fillRef idx="0">
+            <a:schemeClr val="accent1"/>
+          </a:fillRef>
+          <a:effectRef idx="1">
+            <a:schemeClr val="accent1"/>
+          </a:effectRef>
+          <a:fontRef idx="minor">
+            <a:schemeClr val="tx1"/>
+          </a:fontRef>
+        </p:style>
+      </p:cxnSp>
     </p:spTree>
   </p:cSld>
   <p:clrMapOvr>
@@ -18304,7 +18304,7 @@
                 </a:solidFill>
                 <a:latin typeface="DM Serif Display"/>
               </a:rPr>
-              <a:t>PhD B · nog aan te werven</a:t>
+              <a:t>PhD B · nog te selecteren</a:t>
             </a:r>
           </a:p>
         </p:txBody>

</xml_diff>